<commit_message>
remove irrelevent txt file
</commit_message>
<xml_diff>
--- a/p07/A-frame-additional-geom-objects.pptx
+++ b/p07/A-frame-additional-geom-objects.pptx
@@ -9,7 +9,8 @@
     <p:sldId id="259" r:id="rId3"/>
     <p:sldId id="260" r:id="rId4"/>
     <p:sldId id="261" r:id="rId5"/>
-    <p:sldId id="293" r:id="rId6"/>
+    <p:sldId id="296" r:id="rId6"/>
+    <p:sldId id="293" r:id="rId7"/>
   </p:sldIdLst>
   <p:sldSz cx="12192000" cy="6858000"/>
   <p:notesSz cx="6858000" cy="9144000"/>
@@ -247,7 +248,7 @@
           <a:p>
             <a:fld id="{846CE7D5-CF57-46EF-B807-FDD0502418D4}" type="datetimeFigureOut">
               <a:rPr lang="en-US" smtClean="0"/>
-              <a:t>10/19/2024</a:t>
+              <a:t>8/18/2026</a:t>
             </a:fld>
             <a:endParaRPr lang="en-US"/>
           </a:p>
@@ -417,7 +418,7 @@
           <a:p>
             <a:fld id="{846CE7D5-CF57-46EF-B807-FDD0502418D4}" type="datetimeFigureOut">
               <a:rPr lang="en-US" smtClean="0"/>
-              <a:t>10/19/2024</a:t>
+              <a:t>8/18/2026</a:t>
             </a:fld>
             <a:endParaRPr lang="en-US"/>
           </a:p>
@@ -597,7 +598,7 @@
           <a:p>
             <a:fld id="{846CE7D5-CF57-46EF-B807-FDD0502418D4}" type="datetimeFigureOut">
               <a:rPr lang="en-US" smtClean="0"/>
-              <a:t>10/19/2024</a:t>
+              <a:t>8/18/2026</a:t>
             </a:fld>
             <a:endParaRPr lang="en-US"/>
           </a:p>
@@ -767,7 +768,7 @@
           <a:p>
             <a:fld id="{846CE7D5-CF57-46EF-B807-FDD0502418D4}" type="datetimeFigureOut">
               <a:rPr lang="en-US" smtClean="0"/>
-              <a:t>10/19/2024</a:t>
+              <a:t>8/18/2026</a:t>
             </a:fld>
             <a:endParaRPr lang="en-US"/>
           </a:p>
@@ -1013,7 +1014,7 @@
           <a:p>
             <a:fld id="{846CE7D5-CF57-46EF-B807-FDD0502418D4}" type="datetimeFigureOut">
               <a:rPr lang="en-US" smtClean="0"/>
-              <a:t>10/19/2024</a:t>
+              <a:t>8/18/2026</a:t>
             </a:fld>
             <a:endParaRPr lang="en-US"/>
           </a:p>
@@ -1245,7 +1246,7 @@
           <a:p>
             <a:fld id="{846CE7D5-CF57-46EF-B807-FDD0502418D4}" type="datetimeFigureOut">
               <a:rPr lang="en-US" smtClean="0"/>
-              <a:t>10/19/2024</a:t>
+              <a:t>8/18/2026</a:t>
             </a:fld>
             <a:endParaRPr lang="en-US"/>
           </a:p>
@@ -1612,7 +1613,7 @@
           <a:p>
             <a:fld id="{846CE7D5-CF57-46EF-B807-FDD0502418D4}" type="datetimeFigureOut">
               <a:rPr lang="en-US" smtClean="0"/>
-              <a:t>10/19/2024</a:t>
+              <a:t>8/18/2026</a:t>
             </a:fld>
             <a:endParaRPr lang="en-US"/>
           </a:p>
@@ -1730,7 +1731,7 @@
           <a:p>
             <a:fld id="{846CE7D5-CF57-46EF-B807-FDD0502418D4}" type="datetimeFigureOut">
               <a:rPr lang="en-US" smtClean="0"/>
-              <a:t>10/19/2024</a:t>
+              <a:t>8/18/2026</a:t>
             </a:fld>
             <a:endParaRPr lang="en-US"/>
           </a:p>
@@ -1825,7 +1826,7 @@
           <a:p>
             <a:fld id="{846CE7D5-CF57-46EF-B807-FDD0502418D4}" type="datetimeFigureOut">
               <a:rPr lang="en-US" smtClean="0"/>
-              <a:t>10/19/2024</a:t>
+              <a:t>8/18/2026</a:t>
             </a:fld>
             <a:endParaRPr lang="en-US"/>
           </a:p>
@@ -2102,7 +2103,7 @@
           <a:p>
             <a:fld id="{846CE7D5-CF57-46EF-B807-FDD0502418D4}" type="datetimeFigureOut">
               <a:rPr lang="en-US" smtClean="0"/>
-              <a:t>10/19/2024</a:t>
+              <a:t>8/18/2026</a:t>
             </a:fld>
             <a:endParaRPr lang="en-US"/>
           </a:p>
@@ -2359,7 +2360,7 @@
           <a:p>
             <a:fld id="{846CE7D5-CF57-46EF-B807-FDD0502418D4}" type="datetimeFigureOut">
               <a:rPr lang="en-US" smtClean="0"/>
-              <a:t>10/19/2024</a:t>
+              <a:t>8/18/2026</a:t>
             </a:fld>
             <a:endParaRPr lang="en-US"/>
           </a:p>
@@ -2572,7 +2573,7 @@
           <a:p>
             <a:fld id="{846CE7D5-CF57-46EF-B807-FDD0502418D4}" type="datetimeFigureOut">
               <a:rPr lang="en-US" smtClean="0"/>
-              <a:t>10/19/2024</a:t>
+              <a:t>8/18/2026</a:t>
             </a:fld>
             <a:endParaRPr lang="en-US"/>
           </a:p>
@@ -4663,6 +4664,93 @@
           <a:chExt cx="0" cy="0"/>
         </a:xfrm>
       </p:grpSpPr>
+      <p:sp>
+        <p:nvSpPr>
+          <p:cNvPr id="2" name="Title 1">
+            <a:extLst>
+              <a:ext uri="{FF2B5EF4-FFF2-40B4-BE49-F238E27FC236}">
+                <a16:creationId xmlns:a16="http://schemas.microsoft.com/office/drawing/2014/main" id="{1F36EA5E-C9B6-112B-B571-1B0261147BCB}"/>
+              </a:ext>
+            </a:extLst>
+          </p:cNvPr>
+          <p:cNvSpPr>
+            <a:spLocks noGrp="1"/>
+          </p:cNvSpPr>
+          <p:nvPr>
+            <p:ph type="title"/>
+          </p:nvPr>
+        </p:nvSpPr>
+        <p:spPr/>
+        <p:txBody>
+          <a:bodyPr/>
+          <a:lstStyle/>
+          <a:p>
+            <a:r>
+              <a:rPr lang="en-US" dirty="0"/>
+              <a:t>Simulating </a:t>
+            </a:r>
+            <a:r>
+              <a:rPr lang="en-US"/>
+              <a:t>some physics</a:t>
+            </a:r>
+          </a:p>
+        </p:txBody>
+      </p:sp>
+      <p:sp>
+        <p:nvSpPr>
+          <p:cNvPr id="3" name="Content Placeholder 2">
+            <a:extLst>
+              <a:ext uri="{FF2B5EF4-FFF2-40B4-BE49-F238E27FC236}">
+                <a16:creationId xmlns:a16="http://schemas.microsoft.com/office/drawing/2014/main" id="{29625D04-69E4-1897-646C-7233C97A0C9C}"/>
+              </a:ext>
+            </a:extLst>
+          </p:cNvPr>
+          <p:cNvSpPr>
+            <a:spLocks noGrp="1"/>
+          </p:cNvSpPr>
+          <p:nvPr>
+            <p:ph idx="1"/>
+          </p:nvPr>
+        </p:nvSpPr>
+        <p:spPr/>
+        <p:txBody>
+          <a:bodyPr/>
+          <a:lstStyle/>
+          <a:p>
+            <a:endParaRPr lang="en-US"/>
+          </a:p>
+        </p:txBody>
+      </p:sp>
+    </p:spTree>
+    <p:extLst>
+      <p:ext uri="{BB962C8B-B14F-4D97-AF65-F5344CB8AC3E}">
+        <p14:creationId xmlns:p14="http://schemas.microsoft.com/office/powerpoint/2010/main" val="3158254031"/>
+      </p:ext>
+    </p:extLst>
+  </p:cSld>
+  <p:clrMapOvr>
+    <a:masterClrMapping/>
+  </p:clrMapOvr>
+</p:sld>
+</file>
+
+<file path=ppt/slides/slide6.xml><?xml version="1.0" encoding="utf-8"?>
+<p:sld xmlns:a="http://schemas.openxmlformats.org/drawingml/2006/main" xmlns:r="http://schemas.openxmlformats.org/officeDocument/2006/relationships" xmlns:p="http://schemas.openxmlformats.org/presentationml/2006/main">
+  <p:cSld>
+    <p:spTree>
+      <p:nvGrpSpPr>
+        <p:cNvPr id="1" name=""/>
+        <p:cNvGrpSpPr/>
+        <p:nvPr/>
+      </p:nvGrpSpPr>
+      <p:grpSpPr>
+        <a:xfrm>
+          <a:off x="0" y="0"/>
+          <a:ext cx="0" cy="0"/>
+          <a:chOff x="0" y="0"/>
+          <a:chExt cx="0" cy="0"/>
+        </a:xfrm>
+      </p:grpSpPr>
       <p:pic>
         <p:nvPicPr>
           <p:cNvPr id="2" name="Picture 1">

</xml_diff>

<commit_message>
additions from Ani (Anirudh) Magesh
</commit_message>
<xml_diff>
--- a/p07/A-frame-additional-geom-objects.pptx
+++ b/p07/A-frame-additional-geom-objects.pptx
@@ -7,10 +7,14 @@
   <p:sldIdLst>
     <p:sldId id="295" r:id="rId2"/>
     <p:sldId id="259" r:id="rId3"/>
-    <p:sldId id="260" r:id="rId4"/>
-    <p:sldId id="261" r:id="rId5"/>
-    <p:sldId id="296" r:id="rId6"/>
-    <p:sldId id="293" r:id="rId7"/>
+    <p:sldId id="297" r:id="rId4"/>
+    <p:sldId id="299" r:id="rId5"/>
+    <p:sldId id="300" r:id="rId6"/>
+    <p:sldId id="260" r:id="rId7"/>
+    <p:sldId id="261" r:id="rId8"/>
+    <p:sldId id="296" r:id="rId9"/>
+    <p:sldId id="298" r:id="rId10"/>
+    <p:sldId id="293" r:id="rId11"/>
   </p:sldIdLst>
   <p:sldSz cx="12192000" cy="6858000"/>
   <p:notesSz cx="6858000" cy="9144000"/>
@@ -248,7 +252,7 @@
           <a:p>
             <a:fld id="{846CE7D5-CF57-46EF-B807-FDD0502418D4}" type="datetimeFigureOut">
               <a:rPr lang="en-US" smtClean="0"/>
-              <a:t>8/18/2026</a:t>
+              <a:t>8/20/2026</a:t>
             </a:fld>
             <a:endParaRPr lang="en-US"/>
           </a:p>
@@ -418,7 +422,7 @@
           <a:p>
             <a:fld id="{846CE7D5-CF57-46EF-B807-FDD0502418D4}" type="datetimeFigureOut">
               <a:rPr lang="en-US" smtClean="0"/>
-              <a:t>8/18/2026</a:t>
+              <a:t>8/20/2026</a:t>
             </a:fld>
             <a:endParaRPr lang="en-US"/>
           </a:p>
@@ -598,7 +602,7 @@
           <a:p>
             <a:fld id="{846CE7D5-CF57-46EF-B807-FDD0502418D4}" type="datetimeFigureOut">
               <a:rPr lang="en-US" smtClean="0"/>
-              <a:t>8/18/2026</a:t>
+              <a:t>8/20/2026</a:t>
             </a:fld>
             <a:endParaRPr lang="en-US"/>
           </a:p>
@@ -768,7 +772,7 @@
           <a:p>
             <a:fld id="{846CE7D5-CF57-46EF-B807-FDD0502418D4}" type="datetimeFigureOut">
               <a:rPr lang="en-US" smtClean="0"/>
-              <a:t>8/18/2026</a:t>
+              <a:t>8/20/2026</a:t>
             </a:fld>
             <a:endParaRPr lang="en-US"/>
           </a:p>
@@ -1014,7 +1018,7 @@
           <a:p>
             <a:fld id="{846CE7D5-CF57-46EF-B807-FDD0502418D4}" type="datetimeFigureOut">
               <a:rPr lang="en-US" smtClean="0"/>
-              <a:t>8/18/2026</a:t>
+              <a:t>8/20/2026</a:t>
             </a:fld>
             <a:endParaRPr lang="en-US"/>
           </a:p>
@@ -1246,7 +1250,7 @@
           <a:p>
             <a:fld id="{846CE7D5-CF57-46EF-B807-FDD0502418D4}" type="datetimeFigureOut">
               <a:rPr lang="en-US" smtClean="0"/>
-              <a:t>8/18/2026</a:t>
+              <a:t>8/20/2026</a:t>
             </a:fld>
             <a:endParaRPr lang="en-US"/>
           </a:p>
@@ -1613,7 +1617,7 @@
           <a:p>
             <a:fld id="{846CE7D5-CF57-46EF-B807-FDD0502418D4}" type="datetimeFigureOut">
               <a:rPr lang="en-US" smtClean="0"/>
-              <a:t>8/18/2026</a:t>
+              <a:t>8/20/2026</a:t>
             </a:fld>
             <a:endParaRPr lang="en-US"/>
           </a:p>
@@ -1731,7 +1735,7 @@
           <a:p>
             <a:fld id="{846CE7D5-CF57-46EF-B807-FDD0502418D4}" type="datetimeFigureOut">
               <a:rPr lang="en-US" smtClean="0"/>
-              <a:t>8/18/2026</a:t>
+              <a:t>8/20/2026</a:t>
             </a:fld>
             <a:endParaRPr lang="en-US"/>
           </a:p>
@@ -1826,7 +1830,7 @@
           <a:p>
             <a:fld id="{846CE7D5-CF57-46EF-B807-FDD0502418D4}" type="datetimeFigureOut">
               <a:rPr lang="en-US" smtClean="0"/>
-              <a:t>8/18/2026</a:t>
+              <a:t>8/20/2026</a:t>
             </a:fld>
             <a:endParaRPr lang="en-US"/>
           </a:p>
@@ -2103,7 +2107,7 @@
           <a:p>
             <a:fld id="{846CE7D5-CF57-46EF-B807-FDD0502418D4}" type="datetimeFigureOut">
               <a:rPr lang="en-US" smtClean="0"/>
-              <a:t>8/18/2026</a:t>
+              <a:t>8/20/2026</a:t>
             </a:fld>
             <a:endParaRPr lang="en-US"/>
           </a:p>
@@ -2360,7 +2364,7 @@
           <a:p>
             <a:fld id="{846CE7D5-CF57-46EF-B807-FDD0502418D4}" type="datetimeFigureOut">
               <a:rPr lang="en-US" smtClean="0"/>
-              <a:t>8/18/2026</a:t>
+              <a:t>8/20/2026</a:t>
             </a:fld>
             <a:endParaRPr lang="en-US"/>
           </a:p>
@@ -2573,7 +2577,7 @@
           <a:p>
             <a:fld id="{846CE7D5-CF57-46EF-B807-FDD0502418D4}" type="datetimeFigureOut">
               <a:rPr lang="en-US" smtClean="0"/>
-              <a:t>8/18/2026</a:t>
+              <a:t>8/20/2026</a:t>
             </a:fld>
             <a:endParaRPr lang="en-US"/>
           </a:p>
@@ -4250,491 +4254,7 @@
 </p:sld>
 </file>
 
-<file path=ppt/slides/slide2.xml><?xml version="1.0" encoding="utf-8"?>
-<p:sld xmlns:a="http://schemas.openxmlformats.org/drawingml/2006/main" xmlns:r="http://schemas.openxmlformats.org/officeDocument/2006/relationships" xmlns:p="http://schemas.openxmlformats.org/presentationml/2006/main">
-  <p:cSld>
-    <p:spTree>
-      <p:nvGrpSpPr>
-        <p:cNvPr id="1" name=""/>
-        <p:cNvGrpSpPr/>
-        <p:nvPr/>
-      </p:nvGrpSpPr>
-      <p:grpSpPr>
-        <a:xfrm>
-          <a:off x="0" y="0"/>
-          <a:ext cx="0" cy="0"/>
-          <a:chOff x="0" y="0"/>
-          <a:chExt cx="0" cy="0"/>
-        </a:xfrm>
-      </p:grpSpPr>
-      <p:sp>
-        <p:nvSpPr>
-          <p:cNvPr id="2" name="Title 1">
-            <a:extLst>
-              <a:ext uri="{FF2B5EF4-FFF2-40B4-BE49-F238E27FC236}">
-                <a16:creationId xmlns:a16="http://schemas.microsoft.com/office/drawing/2014/main" id="{D0A32E1B-304C-70CA-4FE2-121036B45BBD}"/>
-              </a:ext>
-            </a:extLst>
-          </p:cNvPr>
-          <p:cNvSpPr>
-            <a:spLocks noGrp="1"/>
-          </p:cNvSpPr>
-          <p:nvPr>
-            <p:ph type="title"/>
-          </p:nvPr>
-        </p:nvSpPr>
-        <p:spPr/>
-        <p:txBody>
-          <a:bodyPr/>
-          <a:lstStyle/>
-          <a:p>
-            <a:r>
-              <a:rPr lang="en-US" dirty="0">
-                <a:solidFill>
-                  <a:srgbClr val="0070C0"/>
-                </a:solidFill>
-                <a:ea typeface="Calibri Light"/>
-                <a:cs typeface="Calibri Light"/>
-              </a:rPr>
-              <a:t>Outline</a:t>
-            </a:r>
-            <a:endParaRPr lang="en-US">
-              <a:solidFill>
-                <a:srgbClr val="0070C0"/>
-              </a:solidFill>
-              <a:ea typeface="Calibri Light"/>
-              <a:cs typeface="Calibri Light"/>
-            </a:endParaRPr>
-          </a:p>
-        </p:txBody>
-      </p:sp>
-      <p:sp>
-        <p:nvSpPr>
-          <p:cNvPr id="3" name="Content Placeholder 2">
-            <a:extLst>
-              <a:ext uri="{FF2B5EF4-FFF2-40B4-BE49-F238E27FC236}">
-                <a16:creationId xmlns:a16="http://schemas.microsoft.com/office/drawing/2014/main" id="{0F80D594-86CE-1ED4-994C-042A2971ED94}"/>
-              </a:ext>
-            </a:extLst>
-          </p:cNvPr>
-          <p:cNvSpPr>
-            <a:spLocks noGrp="1"/>
-          </p:cNvSpPr>
-          <p:nvPr>
-            <p:ph idx="1"/>
-          </p:nvPr>
-        </p:nvSpPr>
-        <p:spPr/>
-        <p:txBody>
-          <a:bodyPr vert="horz" lIns="91440" tIns="45720" rIns="91440" bIns="45720" rtlCol="0" anchor="t">
-            <a:normAutofit/>
-          </a:bodyPr>
-          <a:lstStyle/>
-          <a:p>
-            <a:pPr marL="0" indent="0">
-              <a:buNone/>
-            </a:pPr>
-            <a:endParaRPr lang="en-US" dirty="0">
-              <a:ea typeface="Calibri" panose="020F0502020204030204"/>
-              <a:cs typeface="Calibri" panose="020F0502020204030204"/>
-            </a:endParaRPr>
-          </a:p>
-          <a:p>
-            <a:pPr marL="0" indent="0">
-              <a:buNone/>
-            </a:pPr>
-            <a:r>
-              <a:rPr lang="en-US" dirty="0">
-                <a:ea typeface="Calibri" panose="020F0502020204030204"/>
-                <a:cs typeface="Calibri" panose="020F0502020204030204"/>
-              </a:rPr>
-              <a:t>Geometric objects besides A-frame  standard objects</a:t>
-            </a:r>
-          </a:p>
-          <a:p>
-            <a:pPr marL="0" indent="0">
-              <a:buNone/>
-            </a:pPr>
-            <a:endParaRPr lang="en-US" dirty="0">
-              <a:ea typeface="Calibri" panose="020F0502020204030204"/>
-              <a:cs typeface="Calibri" panose="020F0502020204030204"/>
-            </a:endParaRPr>
-          </a:p>
-          <a:p>
-            <a:pPr marL="0" indent="0">
-              <a:buNone/>
-            </a:pPr>
-            <a:r>
-              <a:rPr lang="en-US" dirty="0">
-                <a:ea typeface="Calibri" panose="020F0502020204030204"/>
-                <a:cs typeface="Calibri" panose="020F0502020204030204"/>
-              </a:rPr>
-              <a:t>Windows: Paint3 D</a:t>
-            </a:r>
-          </a:p>
-          <a:p>
-            <a:pPr marL="0" indent="0">
-              <a:buNone/>
-            </a:pPr>
-            <a:r>
-              <a:rPr lang="en-US" dirty="0">
-                <a:ea typeface="Calibri" panose="020F0502020204030204"/>
-                <a:cs typeface="Calibri" panose="020F0502020204030204"/>
-              </a:rPr>
-              <a:t>	Linux, MacOS, Windows: Blender</a:t>
-            </a:r>
-          </a:p>
-          <a:p>
-            <a:pPr marL="0" indent="0">
-              <a:buNone/>
-            </a:pPr>
-            <a:endParaRPr lang="en-US" dirty="0">
-              <a:ea typeface="Calibri" panose="020F0502020204030204"/>
-              <a:cs typeface="Calibri" panose="020F0502020204030204"/>
-            </a:endParaRPr>
-          </a:p>
-          <a:p>
-            <a:pPr marL="0" indent="0">
-              <a:buNone/>
-            </a:pPr>
-            <a:r>
-              <a:rPr lang="en-US" dirty="0">
-                <a:ea typeface="Calibri" panose="020F0502020204030204"/>
-                <a:cs typeface="Calibri" panose="020F0502020204030204"/>
-              </a:rPr>
-              <a:t>Using a </a:t>
-            </a:r>
-            <a:r>
-              <a:rPr lang="en-US" dirty="0" err="1">
-                <a:ea typeface="Calibri" panose="020F0502020204030204"/>
-                <a:cs typeface="Calibri" panose="020F0502020204030204"/>
-              </a:rPr>
-              <a:t>glb</a:t>
-            </a:r>
-            <a:r>
-              <a:rPr lang="en-US" dirty="0">
-                <a:ea typeface="Calibri" panose="020F0502020204030204"/>
-                <a:cs typeface="Calibri" panose="020F0502020204030204"/>
-              </a:rPr>
-              <a:t> file</a:t>
-            </a:r>
-          </a:p>
-        </p:txBody>
-      </p:sp>
-    </p:spTree>
-    <p:extLst>
-      <p:ext uri="{BB962C8B-B14F-4D97-AF65-F5344CB8AC3E}">
-        <p14:creationId xmlns:p14="http://schemas.microsoft.com/office/powerpoint/2010/main" val="1169712265"/>
-      </p:ext>
-    </p:extLst>
-  </p:cSld>
-  <p:clrMapOvr>
-    <a:masterClrMapping/>
-  </p:clrMapOvr>
-</p:sld>
-</file>
-
-<file path=ppt/slides/slide3.xml><?xml version="1.0" encoding="utf-8"?>
-<p:sld xmlns:a="http://schemas.openxmlformats.org/drawingml/2006/main" xmlns:r="http://schemas.openxmlformats.org/officeDocument/2006/relationships" xmlns:p="http://schemas.openxmlformats.org/presentationml/2006/main">
-  <p:cSld>
-    <p:spTree>
-      <p:nvGrpSpPr>
-        <p:cNvPr id="1" name=""/>
-        <p:cNvGrpSpPr/>
-        <p:nvPr/>
-      </p:nvGrpSpPr>
-      <p:grpSpPr>
-        <a:xfrm>
-          <a:off x="0" y="0"/>
-          <a:ext cx="0" cy="0"/>
-          <a:chOff x="0" y="0"/>
-          <a:chExt cx="0" cy="0"/>
-        </a:xfrm>
-      </p:grpSpPr>
-      <p:sp>
-        <p:nvSpPr>
-          <p:cNvPr id="2" name="Title 1">
-            <a:extLst>
-              <a:ext uri="{FF2B5EF4-FFF2-40B4-BE49-F238E27FC236}">
-                <a16:creationId xmlns:a16="http://schemas.microsoft.com/office/drawing/2014/main" id="{E1D58CCF-A4B3-87E5-2361-C8BFA6E4B82F}"/>
-              </a:ext>
-            </a:extLst>
-          </p:cNvPr>
-          <p:cNvSpPr>
-            <a:spLocks noGrp="1"/>
-          </p:cNvSpPr>
-          <p:nvPr>
-            <p:ph type="title"/>
-          </p:nvPr>
-        </p:nvSpPr>
-        <p:spPr/>
-        <p:txBody>
-          <a:bodyPr/>
-          <a:lstStyle/>
-          <a:p>
-            <a:r>
-              <a:rPr lang="en-US" dirty="0"/>
-              <a:t>GLB loader – down in WebGL</a:t>
-            </a:r>
-          </a:p>
-        </p:txBody>
-      </p:sp>
-      <p:sp>
-        <p:nvSpPr>
-          <p:cNvPr id="7" name="Content Placeholder 6">
-            <a:extLst>
-              <a:ext uri="{FF2B5EF4-FFF2-40B4-BE49-F238E27FC236}">
-                <a16:creationId xmlns:a16="http://schemas.microsoft.com/office/drawing/2014/main" id="{2AC5DE7B-616D-07B8-CD59-2E83C6832884}"/>
-              </a:ext>
-            </a:extLst>
-          </p:cNvPr>
-          <p:cNvSpPr>
-            <a:spLocks noGrp="1"/>
-          </p:cNvSpPr>
-          <p:nvPr>
-            <p:ph idx="1"/>
-          </p:nvPr>
-        </p:nvSpPr>
-        <p:spPr/>
-        <p:txBody>
-          <a:bodyPr/>
-          <a:lstStyle/>
-          <a:p>
-            <a:pPr marL="0" indent="0">
-              <a:buNone/>
-            </a:pPr>
-            <a:r>
-              <a:rPr lang="en-US" dirty="0"/>
-              <a:t>GLB or GLFT</a:t>
-            </a:r>
-          </a:p>
-          <a:p>
-            <a:endParaRPr lang="en-US" dirty="0"/>
-          </a:p>
-          <a:p>
-            <a:endParaRPr lang="en-US" dirty="0"/>
-          </a:p>
-        </p:txBody>
-      </p:sp>
-      <p:pic>
-        <p:nvPicPr>
-          <p:cNvPr id="9" name="Picture 8">
-            <a:extLst>
-              <a:ext uri="{FF2B5EF4-FFF2-40B4-BE49-F238E27FC236}">
-                <a16:creationId xmlns:a16="http://schemas.microsoft.com/office/drawing/2014/main" id="{9F20C3C8-7680-0B76-25CE-EEEE69670B56}"/>
-              </a:ext>
-            </a:extLst>
-          </p:cNvPr>
-          <p:cNvPicPr>
-            <a:picLocks noChangeAspect="1"/>
-          </p:cNvPicPr>
-          <p:nvPr/>
-        </p:nvPicPr>
-        <p:blipFill>
-          <a:blip r:embed="rId2"/>
-          <a:stretch>
-            <a:fillRect/>
-          </a:stretch>
-        </p:blipFill>
-        <p:spPr>
-          <a:xfrm>
-            <a:off x="368399" y="2984458"/>
-            <a:ext cx="11269046" cy="2770883"/>
-          </a:xfrm>
-          <a:prstGeom prst="rect">
-            <a:avLst/>
-          </a:prstGeom>
-        </p:spPr>
-      </p:pic>
-    </p:spTree>
-    <p:extLst>
-      <p:ext uri="{BB962C8B-B14F-4D97-AF65-F5344CB8AC3E}">
-        <p14:creationId xmlns:p14="http://schemas.microsoft.com/office/powerpoint/2010/main" val="763447376"/>
-      </p:ext>
-    </p:extLst>
-  </p:cSld>
-  <p:clrMapOvr>
-    <a:masterClrMapping/>
-  </p:clrMapOvr>
-</p:sld>
-</file>
-
-<file path=ppt/slides/slide4.xml><?xml version="1.0" encoding="utf-8"?>
-<p:sld xmlns:a="http://schemas.openxmlformats.org/drawingml/2006/main" xmlns:r="http://schemas.openxmlformats.org/officeDocument/2006/relationships" xmlns:p="http://schemas.openxmlformats.org/presentationml/2006/main">
-  <p:cSld>
-    <p:spTree>
-      <p:nvGrpSpPr>
-        <p:cNvPr id="1" name=""/>
-        <p:cNvGrpSpPr/>
-        <p:nvPr/>
-      </p:nvGrpSpPr>
-      <p:grpSpPr>
-        <a:xfrm>
-          <a:off x="0" y="0"/>
-          <a:ext cx="0" cy="0"/>
-          <a:chOff x="0" y="0"/>
-          <a:chExt cx="0" cy="0"/>
-        </a:xfrm>
-      </p:grpSpPr>
-      <p:sp>
-        <p:nvSpPr>
-          <p:cNvPr id="2" name="Title 1">
-            <a:extLst>
-              <a:ext uri="{FF2B5EF4-FFF2-40B4-BE49-F238E27FC236}">
-                <a16:creationId xmlns:a16="http://schemas.microsoft.com/office/drawing/2014/main" id="{CD55751D-B22E-6AC2-4C52-544EC92C7E2D}"/>
-              </a:ext>
-            </a:extLst>
-          </p:cNvPr>
-          <p:cNvSpPr>
-            <a:spLocks noGrp="1"/>
-          </p:cNvSpPr>
-          <p:nvPr>
-            <p:ph type="title"/>
-          </p:nvPr>
-        </p:nvSpPr>
-        <p:spPr/>
-        <p:txBody>
-          <a:bodyPr/>
-          <a:lstStyle/>
-          <a:p>
-            <a:r>
-              <a:rPr lang="en-US" dirty="0"/>
-              <a:t>Space ship and green cube</a:t>
-            </a:r>
-          </a:p>
-        </p:txBody>
-      </p:sp>
-      <p:pic>
-        <p:nvPicPr>
-          <p:cNvPr id="5" name="Picture 4">
-            <a:extLst>
-              <a:ext uri="{FF2B5EF4-FFF2-40B4-BE49-F238E27FC236}">
-                <a16:creationId xmlns:a16="http://schemas.microsoft.com/office/drawing/2014/main" id="{E3CE7A71-2235-1200-04FE-3E754F489E00}"/>
-              </a:ext>
-            </a:extLst>
-          </p:cNvPr>
-          <p:cNvPicPr>
-            <a:picLocks noChangeAspect="1"/>
-          </p:cNvPicPr>
-          <p:nvPr/>
-        </p:nvPicPr>
-        <p:blipFill>
-          <a:blip r:embed="rId2"/>
-          <a:stretch>
-            <a:fillRect/>
-          </a:stretch>
-        </p:blipFill>
-        <p:spPr>
-          <a:xfrm>
-            <a:off x="1260848" y="2729138"/>
-            <a:ext cx="8686422" cy="1821346"/>
-          </a:xfrm>
-          <a:prstGeom prst="rect">
-            <a:avLst/>
-          </a:prstGeom>
-        </p:spPr>
-      </p:pic>
-    </p:spTree>
-    <p:extLst>
-      <p:ext uri="{BB962C8B-B14F-4D97-AF65-F5344CB8AC3E}">
-        <p14:creationId xmlns:p14="http://schemas.microsoft.com/office/powerpoint/2010/main" val="3561808767"/>
-      </p:ext>
-    </p:extLst>
-  </p:cSld>
-  <p:clrMapOvr>
-    <a:masterClrMapping/>
-  </p:clrMapOvr>
-</p:sld>
-</file>
-
-<file path=ppt/slides/slide5.xml><?xml version="1.0" encoding="utf-8"?>
-<p:sld xmlns:a="http://schemas.openxmlformats.org/drawingml/2006/main" xmlns:r="http://schemas.openxmlformats.org/officeDocument/2006/relationships" xmlns:p="http://schemas.openxmlformats.org/presentationml/2006/main">
-  <p:cSld>
-    <p:spTree>
-      <p:nvGrpSpPr>
-        <p:cNvPr id="1" name=""/>
-        <p:cNvGrpSpPr/>
-        <p:nvPr/>
-      </p:nvGrpSpPr>
-      <p:grpSpPr>
-        <a:xfrm>
-          <a:off x="0" y="0"/>
-          <a:ext cx="0" cy="0"/>
-          <a:chOff x="0" y="0"/>
-          <a:chExt cx="0" cy="0"/>
-        </a:xfrm>
-      </p:grpSpPr>
-      <p:sp>
-        <p:nvSpPr>
-          <p:cNvPr id="2" name="Title 1">
-            <a:extLst>
-              <a:ext uri="{FF2B5EF4-FFF2-40B4-BE49-F238E27FC236}">
-                <a16:creationId xmlns:a16="http://schemas.microsoft.com/office/drawing/2014/main" id="{1F36EA5E-C9B6-112B-B571-1B0261147BCB}"/>
-              </a:ext>
-            </a:extLst>
-          </p:cNvPr>
-          <p:cNvSpPr>
-            <a:spLocks noGrp="1"/>
-          </p:cNvSpPr>
-          <p:nvPr>
-            <p:ph type="title"/>
-          </p:nvPr>
-        </p:nvSpPr>
-        <p:spPr/>
-        <p:txBody>
-          <a:bodyPr/>
-          <a:lstStyle/>
-          <a:p>
-            <a:r>
-              <a:rPr lang="en-US" dirty="0"/>
-              <a:t>Simulating </a:t>
-            </a:r>
-            <a:r>
-              <a:rPr lang="en-US"/>
-              <a:t>some physics</a:t>
-            </a:r>
-          </a:p>
-        </p:txBody>
-      </p:sp>
-      <p:sp>
-        <p:nvSpPr>
-          <p:cNvPr id="3" name="Content Placeholder 2">
-            <a:extLst>
-              <a:ext uri="{FF2B5EF4-FFF2-40B4-BE49-F238E27FC236}">
-                <a16:creationId xmlns:a16="http://schemas.microsoft.com/office/drawing/2014/main" id="{29625D04-69E4-1897-646C-7233C97A0C9C}"/>
-              </a:ext>
-            </a:extLst>
-          </p:cNvPr>
-          <p:cNvSpPr>
-            <a:spLocks noGrp="1"/>
-          </p:cNvSpPr>
-          <p:nvPr>
-            <p:ph idx="1"/>
-          </p:nvPr>
-        </p:nvSpPr>
-        <p:spPr/>
-        <p:txBody>
-          <a:bodyPr/>
-          <a:lstStyle/>
-          <a:p>
-            <a:endParaRPr lang="en-US"/>
-          </a:p>
-        </p:txBody>
-      </p:sp>
-    </p:spTree>
-    <p:extLst>
-      <p:ext uri="{BB962C8B-B14F-4D97-AF65-F5344CB8AC3E}">
-        <p14:creationId xmlns:p14="http://schemas.microsoft.com/office/powerpoint/2010/main" val="3158254031"/>
-      </p:ext>
-    </p:extLst>
-  </p:cSld>
-  <p:clrMapOvr>
-    <a:masterClrMapping/>
-  </p:clrMapOvr>
-</p:sld>
-</file>
-
-<file path=ppt/slides/slide6.xml><?xml version="1.0" encoding="utf-8"?>
+<file path=ppt/slides/slide10.xml><?xml version="1.0" encoding="utf-8"?>
 <p:sld xmlns:a="http://schemas.openxmlformats.org/drawingml/2006/main" xmlns:r="http://schemas.openxmlformats.org/officeDocument/2006/relationships" xmlns:p="http://schemas.openxmlformats.org/presentationml/2006/main">
   <p:cSld>
     <p:spTree>
@@ -4784,6 +4304,1073 @@
     <p:extLst>
       <p:ext uri="{BB962C8B-B14F-4D97-AF65-F5344CB8AC3E}">
         <p14:creationId xmlns:p14="http://schemas.microsoft.com/office/powerpoint/2010/main" val="1758179659"/>
+      </p:ext>
+    </p:extLst>
+  </p:cSld>
+  <p:clrMapOvr>
+    <a:masterClrMapping/>
+  </p:clrMapOvr>
+</p:sld>
+</file>
+
+<file path=ppt/slides/slide2.xml><?xml version="1.0" encoding="utf-8"?>
+<p:sld xmlns:a="http://schemas.openxmlformats.org/drawingml/2006/main" xmlns:r="http://schemas.openxmlformats.org/officeDocument/2006/relationships" xmlns:p="http://schemas.openxmlformats.org/presentationml/2006/main">
+  <p:cSld>
+    <p:spTree>
+      <p:nvGrpSpPr>
+        <p:cNvPr id="1" name=""/>
+        <p:cNvGrpSpPr/>
+        <p:nvPr/>
+      </p:nvGrpSpPr>
+      <p:grpSpPr>
+        <a:xfrm>
+          <a:off x="0" y="0"/>
+          <a:ext cx="0" cy="0"/>
+          <a:chOff x="0" y="0"/>
+          <a:chExt cx="0" cy="0"/>
+        </a:xfrm>
+      </p:grpSpPr>
+      <p:sp>
+        <p:nvSpPr>
+          <p:cNvPr id="2" name="Title 1">
+            <a:extLst>
+              <a:ext uri="{FF2B5EF4-FFF2-40B4-BE49-F238E27FC236}">
+                <a16:creationId xmlns:a16="http://schemas.microsoft.com/office/drawing/2014/main" id="{D0A32E1B-304C-70CA-4FE2-121036B45BBD}"/>
+              </a:ext>
+            </a:extLst>
+          </p:cNvPr>
+          <p:cNvSpPr>
+            <a:spLocks noGrp="1"/>
+          </p:cNvSpPr>
+          <p:nvPr>
+            <p:ph type="title"/>
+          </p:nvPr>
+        </p:nvSpPr>
+        <p:spPr/>
+        <p:txBody>
+          <a:bodyPr/>
+          <a:lstStyle/>
+          <a:p>
+            <a:r>
+              <a:rPr lang="en-US" dirty="0">
+                <a:solidFill>
+                  <a:srgbClr val="0070C0"/>
+                </a:solidFill>
+                <a:ea typeface="Calibri Light"/>
+                <a:cs typeface="Calibri Light"/>
+              </a:rPr>
+              <a:t>Outline</a:t>
+            </a:r>
+            <a:endParaRPr lang="en-US">
+              <a:solidFill>
+                <a:srgbClr val="0070C0"/>
+              </a:solidFill>
+              <a:ea typeface="Calibri Light"/>
+              <a:cs typeface="Calibri Light"/>
+            </a:endParaRPr>
+          </a:p>
+        </p:txBody>
+      </p:sp>
+      <p:sp>
+        <p:nvSpPr>
+          <p:cNvPr id="3" name="Content Placeholder 2">
+            <a:extLst>
+              <a:ext uri="{FF2B5EF4-FFF2-40B4-BE49-F238E27FC236}">
+                <a16:creationId xmlns:a16="http://schemas.microsoft.com/office/drawing/2014/main" id="{0F80D594-86CE-1ED4-994C-042A2971ED94}"/>
+              </a:ext>
+            </a:extLst>
+          </p:cNvPr>
+          <p:cNvSpPr>
+            <a:spLocks noGrp="1"/>
+          </p:cNvSpPr>
+          <p:nvPr>
+            <p:ph idx="1"/>
+          </p:nvPr>
+        </p:nvSpPr>
+        <p:spPr/>
+        <p:txBody>
+          <a:bodyPr vert="horz" lIns="91440" tIns="45720" rIns="91440" bIns="45720" rtlCol="0" anchor="t">
+            <a:normAutofit/>
+          </a:bodyPr>
+          <a:lstStyle/>
+          <a:p>
+            <a:pPr marL="0" indent="0">
+              <a:buNone/>
+            </a:pPr>
+            <a:endParaRPr lang="en-US" dirty="0">
+              <a:ea typeface="Calibri" panose="020F0502020204030204"/>
+              <a:cs typeface="Calibri" panose="020F0502020204030204"/>
+            </a:endParaRPr>
+          </a:p>
+          <a:p>
+            <a:pPr marL="0" indent="0">
+              <a:buNone/>
+            </a:pPr>
+            <a:r>
+              <a:rPr lang="en-US" dirty="0">
+                <a:ea typeface="Calibri" panose="020F0502020204030204"/>
+                <a:cs typeface="Calibri" panose="020F0502020204030204"/>
+              </a:rPr>
+              <a:t>Geometric objects besides A-frame  standard objects</a:t>
+            </a:r>
+          </a:p>
+          <a:p>
+            <a:pPr marL="0" indent="0">
+              <a:buNone/>
+            </a:pPr>
+            <a:endParaRPr lang="en-US" dirty="0">
+              <a:ea typeface="Calibri" panose="020F0502020204030204"/>
+              <a:cs typeface="Calibri" panose="020F0502020204030204"/>
+            </a:endParaRPr>
+          </a:p>
+          <a:p>
+            <a:pPr marL="0" indent="0">
+              <a:buNone/>
+            </a:pPr>
+            <a:r>
+              <a:rPr lang="en-US" dirty="0">
+                <a:ea typeface="Calibri" panose="020F0502020204030204"/>
+                <a:cs typeface="Calibri" panose="020F0502020204030204"/>
+              </a:rPr>
+              <a:t>Windows: Paint3 D</a:t>
+            </a:r>
+          </a:p>
+          <a:p>
+            <a:pPr marL="0" indent="0">
+              <a:buNone/>
+            </a:pPr>
+            <a:r>
+              <a:rPr lang="en-US" dirty="0">
+                <a:ea typeface="Calibri" panose="020F0502020204030204"/>
+                <a:cs typeface="Calibri" panose="020F0502020204030204"/>
+              </a:rPr>
+              <a:t>	Linux, MacOS, Windows: Blender</a:t>
+            </a:r>
+          </a:p>
+          <a:p>
+            <a:pPr marL="0" indent="0">
+              <a:buNone/>
+            </a:pPr>
+            <a:endParaRPr lang="en-US" dirty="0">
+              <a:ea typeface="Calibri" panose="020F0502020204030204"/>
+              <a:cs typeface="Calibri" panose="020F0502020204030204"/>
+            </a:endParaRPr>
+          </a:p>
+          <a:p>
+            <a:pPr marL="0" indent="0">
+              <a:buNone/>
+            </a:pPr>
+            <a:r>
+              <a:rPr lang="en-US" dirty="0">
+                <a:ea typeface="Calibri" panose="020F0502020204030204"/>
+                <a:cs typeface="Calibri" panose="020F0502020204030204"/>
+              </a:rPr>
+              <a:t>Using a </a:t>
+            </a:r>
+            <a:r>
+              <a:rPr lang="en-US" dirty="0" err="1">
+                <a:ea typeface="Calibri" panose="020F0502020204030204"/>
+                <a:cs typeface="Calibri" panose="020F0502020204030204"/>
+              </a:rPr>
+              <a:t>glb</a:t>
+            </a:r>
+            <a:r>
+              <a:rPr lang="en-US" dirty="0">
+                <a:ea typeface="Calibri" panose="020F0502020204030204"/>
+                <a:cs typeface="Calibri" panose="020F0502020204030204"/>
+              </a:rPr>
+              <a:t> file</a:t>
+            </a:r>
+          </a:p>
+        </p:txBody>
+      </p:sp>
+    </p:spTree>
+    <p:extLst>
+      <p:ext uri="{BB962C8B-B14F-4D97-AF65-F5344CB8AC3E}">
+        <p14:creationId xmlns:p14="http://schemas.microsoft.com/office/powerpoint/2010/main" val="1169712265"/>
+      </p:ext>
+    </p:extLst>
+  </p:cSld>
+  <p:clrMapOvr>
+    <a:masterClrMapping/>
+  </p:clrMapOvr>
+</p:sld>
+</file>
+
+<file path=ppt/slides/slide3.xml><?xml version="1.0" encoding="utf-8"?>
+<p:sld xmlns:a="http://schemas.openxmlformats.org/drawingml/2006/main" xmlns:r="http://schemas.openxmlformats.org/officeDocument/2006/relationships" xmlns:p="http://schemas.openxmlformats.org/presentationml/2006/main">
+  <p:cSld>
+    <p:spTree>
+      <p:nvGrpSpPr>
+        <p:cNvPr id="1" name=""/>
+        <p:cNvGrpSpPr/>
+        <p:nvPr/>
+      </p:nvGrpSpPr>
+      <p:grpSpPr>
+        <a:xfrm>
+          <a:off x="0" y="0"/>
+          <a:ext cx="0" cy="0"/>
+          <a:chOff x="0" y="0"/>
+          <a:chExt cx="0" cy="0"/>
+        </a:xfrm>
+      </p:grpSpPr>
+      <p:sp>
+        <p:nvSpPr>
+          <p:cNvPr id="2" name="Title 1">
+            <a:extLst>
+              <a:ext uri="{FF2B5EF4-FFF2-40B4-BE49-F238E27FC236}">
+                <a16:creationId xmlns:a16="http://schemas.microsoft.com/office/drawing/2014/main" id="{A635440D-B8A7-D8A1-750E-2447AE1EAEC5}"/>
+              </a:ext>
+            </a:extLst>
+          </p:cNvPr>
+          <p:cNvSpPr>
+            <a:spLocks noGrp="1"/>
+          </p:cNvSpPr>
+          <p:nvPr>
+            <p:ph type="title"/>
+          </p:nvPr>
+        </p:nvSpPr>
+        <p:spPr/>
+        <p:txBody>
+          <a:bodyPr/>
+          <a:lstStyle/>
+          <a:p>
+            <a:r>
+              <a:rPr lang="en-US" b="1" dirty="0">
+                <a:solidFill>
+                  <a:srgbClr val="0070C0"/>
+                </a:solidFill>
+              </a:rPr>
+              <a:t>Ball Drop Code Explanation</a:t>
+            </a:r>
+            <a:endParaRPr lang="en-US" dirty="0">
+              <a:solidFill>
+                <a:srgbClr val="0070C0"/>
+              </a:solidFill>
+            </a:endParaRPr>
+          </a:p>
+        </p:txBody>
+      </p:sp>
+      <p:sp>
+        <p:nvSpPr>
+          <p:cNvPr id="3" name="Content Placeholder 2">
+            <a:extLst>
+              <a:ext uri="{FF2B5EF4-FFF2-40B4-BE49-F238E27FC236}">
+                <a16:creationId xmlns:a16="http://schemas.microsoft.com/office/drawing/2014/main" id="{9BB8CE97-8D37-3764-3105-4B6C46D3D345}"/>
+              </a:ext>
+            </a:extLst>
+          </p:cNvPr>
+          <p:cNvSpPr>
+            <a:spLocks noGrp="1"/>
+          </p:cNvSpPr>
+          <p:nvPr>
+            <p:ph idx="1"/>
+          </p:nvPr>
+        </p:nvSpPr>
+        <p:spPr/>
+        <p:txBody>
+          <a:bodyPr/>
+          <a:lstStyle/>
+          <a:p>
+            <a:pPr marL="0" indent="0">
+              <a:buNone/>
+            </a:pPr>
+            <a:r>
+              <a:rPr lang="en-US" dirty="0">
+                <a:solidFill>
+                  <a:srgbClr val="0070C0"/>
+                </a:solidFill>
+              </a:rPr>
+              <a:t>In the component’s schema</a:t>
+            </a:r>
+          </a:p>
+          <a:p>
+            <a:pPr marL="0" indent="0">
+              <a:buNone/>
+            </a:pPr>
+            <a:endParaRPr lang="en-US" dirty="0"/>
+          </a:p>
+          <a:p>
+            <a:pPr marL="0" lvl="0" indent="0">
+              <a:buNone/>
+            </a:pPr>
+            <a:r>
+              <a:rPr lang="en-US" b="1" dirty="0" err="1"/>
+              <a:t>startY</a:t>
+            </a:r>
+            <a:r>
+              <a:rPr lang="en-US" dirty="0"/>
+              <a:t> — how high up the ball starts (default: 5)</a:t>
+            </a:r>
+          </a:p>
+          <a:p>
+            <a:pPr marL="0" lvl="0" indent="0">
+              <a:buNone/>
+            </a:pPr>
+            <a:r>
+              <a:rPr lang="en-US" b="1" dirty="0" err="1"/>
+              <a:t>groundY</a:t>
+            </a:r>
+            <a:r>
+              <a:rPr lang="en-US" dirty="0"/>
+              <a:t> — the height of the floor, so the ball knows where to stop (default: 0.5)</a:t>
+            </a:r>
+          </a:p>
+          <a:p>
+            <a:pPr marL="0" lvl="0" indent="0">
+              <a:buNone/>
+            </a:pPr>
+            <a:r>
+              <a:rPr lang="en-US" b="1" dirty="0"/>
+              <a:t>gravity</a:t>
+            </a:r>
+            <a:r>
+              <a:rPr lang="en-US" dirty="0"/>
+              <a:t> — acceleration due to gravity (default: ~ 9.8 m/s</a:t>
+            </a:r>
+            <a:r>
+              <a:rPr lang="en-US" baseline="30000" dirty="0"/>
+              <a:t>2</a:t>
+            </a:r>
+            <a:r>
+              <a:rPr lang="en-US" dirty="0"/>
+              <a:t>  at sea level</a:t>
+            </a:r>
+          </a:p>
+          <a:p>
+            <a:pPr marL="0" lvl="0" indent="0">
+              <a:buNone/>
+            </a:pPr>
+            <a:r>
+              <a:rPr lang="en-US" b="1" dirty="0"/>
+              <a:t>bounce</a:t>
+            </a:r>
+            <a:r>
+              <a:rPr lang="en-US" dirty="0"/>
+              <a:t> —speed the ball keeps after each bounce (default: 0.6, meaning it keeps 60% of its speed)</a:t>
+            </a:r>
+          </a:p>
+          <a:p>
+            <a:pPr marL="0" indent="0">
+              <a:buNone/>
+            </a:pPr>
+            <a:endParaRPr lang="en-US" dirty="0"/>
+          </a:p>
+        </p:txBody>
+      </p:sp>
+    </p:spTree>
+    <p:extLst>
+      <p:ext uri="{BB962C8B-B14F-4D97-AF65-F5344CB8AC3E}">
+        <p14:creationId xmlns:p14="http://schemas.microsoft.com/office/powerpoint/2010/main" val="2512019310"/>
+      </p:ext>
+    </p:extLst>
+  </p:cSld>
+  <p:clrMapOvr>
+    <a:masterClrMapping/>
+  </p:clrMapOvr>
+</p:sld>
+</file>
+
+<file path=ppt/slides/slide4.xml><?xml version="1.0" encoding="utf-8"?>
+<p:sld xmlns:a="http://schemas.openxmlformats.org/drawingml/2006/main" xmlns:r="http://schemas.openxmlformats.org/officeDocument/2006/relationships" xmlns:p="http://schemas.openxmlformats.org/presentationml/2006/main">
+  <p:cSld>
+    <p:spTree>
+      <p:nvGrpSpPr>
+        <p:cNvPr id="1" name=""/>
+        <p:cNvGrpSpPr/>
+        <p:nvPr/>
+      </p:nvGrpSpPr>
+      <p:grpSpPr>
+        <a:xfrm>
+          <a:off x="0" y="0"/>
+          <a:ext cx="0" cy="0"/>
+          <a:chOff x="0" y="0"/>
+          <a:chExt cx="0" cy="0"/>
+        </a:xfrm>
+      </p:grpSpPr>
+      <p:sp>
+        <p:nvSpPr>
+          <p:cNvPr id="2" name="Title 1">
+            <a:extLst>
+              <a:ext uri="{FF2B5EF4-FFF2-40B4-BE49-F238E27FC236}">
+                <a16:creationId xmlns:a16="http://schemas.microsoft.com/office/drawing/2014/main" id="{B4465A59-33B7-13FC-E4CF-CD96761F4582}"/>
+              </a:ext>
+            </a:extLst>
+          </p:cNvPr>
+          <p:cNvSpPr>
+            <a:spLocks noGrp="1"/>
+          </p:cNvSpPr>
+          <p:nvPr>
+            <p:ph type="title"/>
+          </p:nvPr>
+        </p:nvSpPr>
+        <p:spPr/>
+        <p:txBody>
+          <a:bodyPr/>
+          <a:lstStyle/>
+          <a:p>
+            <a:r>
+              <a:rPr lang="en-US" dirty="0"/>
+              <a:t>Init function</a:t>
+            </a:r>
+          </a:p>
+        </p:txBody>
+      </p:sp>
+      <p:sp>
+        <p:nvSpPr>
+          <p:cNvPr id="3" name="Content Placeholder 2">
+            <a:extLst>
+              <a:ext uri="{FF2B5EF4-FFF2-40B4-BE49-F238E27FC236}">
+                <a16:creationId xmlns:a16="http://schemas.microsoft.com/office/drawing/2014/main" id="{F658EB5A-9DCA-E4A1-02DE-87A38DE5D78A}"/>
+              </a:ext>
+            </a:extLst>
+          </p:cNvPr>
+          <p:cNvSpPr>
+            <a:spLocks noGrp="1"/>
+          </p:cNvSpPr>
+          <p:nvPr>
+            <p:ph idx="1"/>
+          </p:nvPr>
+        </p:nvSpPr>
+        <p:spPr/>
+        <p:txBody>
+          <a:bodyPr/>
+          <a:lstStyle/>
+          <a:p>
+            <a:pPr marL="0" indent="0">
+              <a:buNone/>
+            </a:pPr>
+            <a:r>
+              <a:rPr lang="en-US" dirty="0"/>
+              <a:t>Init is run only once on creation of the A-frame component</a:t>
+            </a:r>
+          </a:p>
+          <a:p>
+            <a:pPr marL="0" indent="0">
+              <a:buNone/>
+            </a:pPr>
+            <a:endParaRPr lang="en-US" dirty="0"/>
+          </a:p>
+          <a:p>
+            <a:pPr marL="514350" lvl="0" indent="-514350">
+              <a:buFont typeface="+mj-lt"/>
+              <a:buAutoNum type="arabicPeriod"/>
+            </a:pPr>
+            <a:r>
+              <a:rPr lang="en-US" dirty="0"/>
+              <a:t>Init sets the ball’s starting speed to 0 (not moving yet) and places it at the starting height.</a:t>
+            </a:r>
+          </a:p>
+          <a:p>
+            <a:pPr marL="514350" lvl="0" indent="-514350">
+              <a:buFont typeface="+mj-lt"/>
+              <a:buAutoNum type="arabicPeriod"/>
+            </a:pPr>
+            <a:r>
+              <a:rPr lang="en-US" dirty="0"/>
+              <a:t>It sets up a click listener on the ball — so if you click it, it jumps back to the starting height and its speed resets to 0. This is what lets you drop it again after it lands</a:t>
+            </a:r>
+          </a:p>
+          <a:p>
+            <a:pPr marL="514350" lvl="0" indent="-514350">
+              <a:buFont typeface="+mj-lt"/>
+              <a:buAutoNum type="arabicPeriod"/>
+            </a:pPr>
+            <a:r>
+              <a:rPr lang="en-US" dirty="0"/>
+              <a:t>Ensure to remove the event listener in the remove function</a:t>
+            </a:r>
+          </a:p>
+          <a:p>
+            <a:pPr marL="0" indent="0">
+              <a:buNone/>
+            </a:pPr>
+            <a:endParaRPr lang="en-US" dirty="0"/>
+          </a:p>
+        </p:txBody>
+      </p:sp>
+    </p:spTree>
+    <p:extLst>
+      <p:ext uri="{BB962C8B-B14F-4D97-AF65-F5344CB8AC3E}">
+        <p14:creationId xmlns:p14="http://schemas.microsoft.com/office/powerpoint/2010/main" val="1835779231"/>
+      </p:ext>
+    </p:extLst>
+  </p:cSld>
+  <p:clrMapOvr>
+    <a:masterClrMapping/>
+  </p:clrMapOvr>
+</p:sld>
+</file>
+
+<file path=ppt/slides/slide5.xml><?xml version="1.0" encoding="utf-8"?>
+<p:sld xmlns:a="http://schemas.openxmlformats.org/drawingml/2006/main" xmlns:r="http://schemas.openxmlformats.org/officeDocument/2006/relationships" xmlns:p="http://schemas.openxmlformats.org/presentationml/2006/main">
+  <p:cSld>
+    <p:spTree>
+      <p:nvGrpSpPr>
+        <p:cNvPr id="1" name=""/>
+        <p:cNvGrpSpPr/>
+        <p:nvPr/>
+      </p:nvGrpSpPr>
+      <p:grpSpPr>
+        <a:xfrm>
+          <a:off x="0" y="0"/>
+          <a:ext cx="0" cy="0"/>
+          <a:chOff x="0" y="0"/>
+          <a:chExt cx="0" cy="0"/>
+        </a:xfrm>
+      </p:grpSpPr>
+      <p:sp>
+        <p:nvSpPr>
+          <p:cNvPr id="2" name="Title 1">
+            <a:extLst>
+              <a:ext uri="{FF2B5EF4-FFF2-40B4-BE49-F238E27FC236}">
+                <a16:creationId xmlns:a16="http://schemas.microsoft.com/office/drawing/2014/main" id="{4BC22660-D65D-771F-03B8-43DA2B90EA4E}"/>
+              </a:ext>
+            </a:extLst>
+          </p:cNvPr>
+          <p:cNvSpPr>
+            <a:spLocks noGrp="1"/>
+          </p:cNvSpPr>
+          <p:nvPr>
+            <p:ph type="title"/>
+          </p:nvPr>
+        </p:nvSpPr>
+        <p:spPr/>
+        <p:txBody>
+          <a:bodyPr/>
+          <a:lstStyle/>
+          <a:p>
+            <a:r>
+              <a:rPr lang="en-US" dirty="0"/>
+              <a:t>Tick function</a:t>
+            </a:r>
+          </a:p>
+        </p:txBody>
+      </p:sp>
+      <p:sp>
+        <p:nvSpPr>
+          <p:cNvPr id="3" name="Content Placeholder 2">
+            <a:extLst>
+              <a:ext uri="{FF2B5EF4-FFF2-40B4-BE49-F238E27FC236}">
+                <a16:creationId xmlns:a16="http://schemas.microsoft.com/office/drawing/2014/main" id="{366E8D71-0976-4B72-6F5A-44318C6094B8}"/>
+              </a:ext>
+            </a:extLst>
+          </p:cNvPr>
+          <p:cNvSpPr>
+            <a:spLocks noGrp="1"/>
+          </p:cNvSpPr>
+          <p:nvPr>
+            <p:ph idx="1"/>
+          </p:nvPr>
+        </p:nvSpPr>
+        <p:spPr/>
+        <p:txBody>
+          <a:bodyPr>
+            <a:normAutofit fontScale="85000" lnSpcReduction="20000"/>
+          </a:bodyPr>
+          <a:lstStyle/>
+          <a:p>
+            <a:pPr marL="0" indent="0">
+              <a:buNone/>
+            </a:pPr>
+            <a:r>
+              <a:rPr lang="en-US" dirty="0"/>
+              <a:t>Every time the frame is drawn (redrawn)</a:t>
+            </a:r>
+          </a:p>
+          <a:p>
+            <a:pPr marL="0" indent="0">
+              <a:buNone/>
+            </a:pPr>
+            <a:endParaRPr lang="en-US" dirty="0"/>
+          </a:p>
+          <a:p>
+            <a:pPr marL="514350" indent="-514350">
+              <a:buFont typeface="+mj-lt"/>
+              <a:buAutoNum type="arabicPeriod"/>
+            </a:pPr>
+            <a:r>
+              <a:rPr lang="en-US" b="1" dirty="0"/>
+              <a:t>Update the ball’s speed.</a:t>
+            </a:r>
+            <a:r>
+              <a:rPr lang="en-US" dirty="0"/>
+              <a:t> It takes the current downward speed and adds a bit more to it, based on gravity. Since this happens dozens of times per second, the ball doesn’t just fall at a constant rate — it keeps speeding up the longer it falls, exactly like a real object would.</a:t>
+            </a:r>
+          </a:p>
+          <a:p>
+            <a:pPr marL="514350" indent="-514350">
+              <a:buFont typeface="+mj-lt"/>
+              <a:buAutoNum type="arabicPeriod"/>
+            </a:pPr>
+            <a:r>
+              <a:rPr lang="en-US" b="1" dirty="0"/>
+              <a:t>Move the ball.</a:t>
+            </a:r>
+            <a:r>
+              <a:rPr lang="en-US" dirty="0"/>
+              <a:t> Now that we know how fast the ball is moving this frame, we use that speed to actually change its position — moving it down a little bit.</a:t>
+            </a:r>
+          </a:p>
+          <a:p>
+            <a:pPr marL="514350" indent="-514350">
+              <a:buFont typeface="+mj-lt"/>
+              <a:buAutoNum type="arabicPeriod"/>
+            </a:pPr>
+            <a:r>
+              <a:rPr lang="en-US" b="1" dirty="0"/>
+              <a:t>Check if the ball hit the ground.</a:t>
+            </a:r>
+            <a:r>
+              <a:rPr lang="en-US" dirty="0"/>
+              <a:t> If the ball’s current height is at or below the floor level, two things happen: </a:t>
+            </a:r>
+          </a:p>
+          <a:p>
+            <a:pPr marL="914400" lvl="1" indent="-457200">
+              <a:buFont typeface="+mj-lt"/>
+              <a:buAutoNum type="alphaLcParenR"/>
+            </a:pPr>
+            <a:r>
+              <a:rPr lang="en-US" dirty="0"/>
+              <a:t>the ball gets snapped exactly onto the floor (so it doesn’t look like it’s sinking into it), and</a:t>
+            </a:r>
+          </a:p>
+          <a:p>
+            <a:pPr marL="914400" lvl="1" indent="-457200">
+              <a:buFont typeface="+mj-lt"/>
+              <a:buAutoNum type="alphaLcParenR"/>
+            </a:pPr>
+            <a:r>
+              <a:rPr lang="en-US" dirty="0"/>
+              <a:t>its speed gets flipped from falling to bouncing — but reduced, using that “bounce” setting. So if it was falling fast, it now bounces back up, but slower than it was falling. </a:t>
+            </a:r>
+          </a:p>
+          <a:p>
+            <a:pPr marL="914400" lvl="1" indent="-457200">
+              <a:buFont typeface="+mj-lt"/>
+              <a:buAutoNum type="alphaLcParenR"/>
+            </a:pPr>
+            <a:r>
+              <a:rPr lang="en-US" dirty="0"/>
+              <a:t>There’s a check that once the bounce speed gets really small, it stops.</a:t>
+            </a:r>
+          </a:p>
+          <a:p>
+            <a:pPr marL="0" indent="0">
+              <a:buNone/>
+            </a:pPr>
+            <a:endParaRPr lang="en-US" dirty="0"/>
+          </a:p>
+        </p:txBody>
+      </p:sp>
+    </p:spTree>
+    <p:extLst>
+      <p:ext uri="{BB962C8B-B14F-4D97-AF65-F5344CB8AC3E}">
+        <p14:creationId xmlns:p14="http://schemas.microsoft.com/office/powerpoint/2010/main" val="2696290654"/>
+      </p:ext>
+    </p:extLst>
+  </p:cSld>
+  <p:clrMapOvr>
+    <a:masterClrMapping/>
+  </p:clrMapOvr>
+</p:sld>
+</file>
+
+<file path=ppt/slides/slide6.xml><?xml version="1.0" encoding="utf-8"?>
+<p:sld xmlns:a="http://schemas.openxmlformats.org/drawingml/2006/main" xmlns:r="http://schemas.openxmlformats.org/officeDocument/2006/relationships" xmlns:p="http://schemas.openxmlformats.org/presentationml/2006/main">
+  <p:cSld>
+    <p:spTree>
+      <p:nvGrpSpPr>
+        <p:cNvPr id="1" name=""/>
+        <p:cNvGrpSpPr/>
+        <p:nvPr/>
+      </p:nvGrpSpPr>
+      <p:grpSpPr>
+        <a:xfrm>
+          <a:off x="0" y="0"/>
+          <a:ext cx="0" cy="0"/>
+          <a:chOff x="0" y="0"/>
+          <a:chExt cx="0" cy="0"/>
+        </a:xfrm>
+      </p:grpSpPr>
+      <p:sp>
+        <p:nvSpPr>
+          <p:cNvPr id="2" name="Title 1">
+            <a:extLst>
+              <a:ext uri="{FF2B5EF4-FFF2-40B4-BE49-F238E27FC236}">
+                <a16:creationId xmlns:a16="http://schemas.microsoft.com/office/drawing/2014/main" id="{E1D58CCF-A4B3-87E5-2361-C8BFA6E4B82F}"/>
+              </a:ext>
+            </a:extLst>
+          </p:cNvPr>
+          <p:cNvSpPr>
+            <a:spLocks noGrp="1"/>
+          </p:cNvSpPr>
+          <p:nvPr>
+            <p:ph type="title"/>
+          </p:nvPr>
+        </p:nvSpPr>
+        <p:spPr/>
+        <p:txBody>
+          <a:bodyPr/>
+          <a:lstStyle/>
+          <a:p>
+            <a:r>
+              <a:rPr lang="en-US" dirty="0"/>
+              <a:t>GLB loader – down in WebGL</a:t>
+            </a:r>
+          </a:p>
+        </p:txBody>
+      </p:sp>
+      <p:sp>
+        <p:nvSpPr>
+          <p:cNvPr id="7" name="Content Placeholder 6">
+            <a:extLst>
+              <a:ext uri="{FF2B5EF4-FFF2-40B4-BE49-F238E27FC236}">
+                <a16:creationId xmlns:a16="http://schemas.microsoft.com/office/drawing/2014/main" id="{2AC5DE7B-616D-07B8-CD59-2E83C6832884}"/>
+              </a:ext>
+            </a:extLst>
+          </p:cNvPr>
+          <p:cNvSpPr>
+            <a:spLocks noGrp="1"/>
+          </p:cNvSpPr>
+          <p:nvPr>
+            <p:ph idx="1"/>
+          </p:nvPr>
+        </p:nvSpPr>
+        <p:spPr/>
+        <p:txBody>
+          <a:bodyPr/>
+          <a:lstStyle/>
+          <a:p>
+            <a:pPr marL="0" indent="0">
+              <a:buNone/>
+            </a:pPr>
+            <a:r>
+              <a:rPr lang="en-US" dirty="0"/>
+              <a:t>GLB or GLFT</a:t>
+            </a:r>
+          </a:p>
+          <a:p>
+            <a:endParaRPr lang="en-US" dirty="0"/>
+          </a:p>
+          <a:p>
+            <a:endParaRPr lang="en-US" dirty="0"/>
+          </a:p>
+        </p:txBody>
+      </p:sp>
+      <p:pic>
+        <p:nvPicPr>
+          <p:cNvPr id="9" name="Picture 8">
+            <a:extLst>
+              <a:ext uri="{FF2B5EF4-FFF2-40B4-BE49-F238E27FC236}">
+                <a16:creationId xmlns:a16="http://schemas.microsoft.com/office/drawing/2014/main" id="{9F20C3C8-7680-0B76-25CE-EEEE69670B56}"/>
+              </a:ext>
+            </a:extLst>
+          </p:cNvPr>
+          <p:cNvPicPr>
+            <a:picLocks noChangeAspect="1"/>
+          </p:cNvPicPr>
+          <p:nvPr/>
+        </p:nvPicPr>
+        <p:blipFill>
+          <a:blip r:embed="rId2"/>
+          <a:stretch>
+            <a:fillRect/>
+          </a:stretch>
+        </p:blipFill>
+        <p:spPr>
+          <a:xfrm>
+            <a:off x="368399" y="2984458"/>
+            <a:ext cx="11269046" cy="2770883"/>
+          </a:xfrm>
+          <a:prstGeom prst="rect">
+            <a:avLst/>
+          </a:prstGeom>
+        </p:spPr>
+      </p:pic>
+    </p:spTree>
+    <p:extLst>
+      <p:ext uri="{BB962C8B-B14F-4D97-AF65-F5344CB8AC3E}">
+        <p14:creationId xmlns:p14="http://schemas.microsoft.com/office/powerpoint/2010/main" val="763447376"/>
+      </p:ext>
+    </p:extLst>
+  </p:cSld>
+  <p:clrMapOvr>
+    <a:masterClrMapping/>
+  </p:clrMapOvr>
+</p:sld>
+</file>
+
+<file path=ppt/slides/slide7.xml><?xml version="1.0" encoding="utf-8"?>
+<p:sld xmlns:a="http://schemas.openxmlformats.org/drawingml/2006/main" xmlns:r="http://schemas.openxmlformats.org/officeDocument/2006/relationships" xmlns:p="http://schemas.openxmlformats.org/presentationml/2006/main">
+  <p:cSld>
+    <p:spTree>
+      <p:nvGrpSpPr>
+        <p:cNvPr id="1" name=""/>
+        <p:cNvGrpSpPr/>
+        <p:nvPr/>
+      </p:nvGrpSpPr>
+      <p:grpSpPr>
+        <a:xfrm>
+          <a:off x="0" y="0"/>
+          <a:ext cx="0" cy="0"/>
+          <a:chOff x="0" y="0"/>
+          <a:chExt cx="0" cy="0"/>
+        </a:xfrm>
+      </p:grpSpPr>
+      <p:sp>
+        <p:nvSpPr>
+          <p:cNvPr id="2" name="Title 1">
+            <a:extLst>
+              <a:ext uri="{FF2B5EF4-FFF2-40B4-BE49-F238E27FC236}">
+                <a16:creationId xmlns:a16="http://schemas.microsoft.com/office/drawing/2014/main" id="{CD55751D-B22E-6AC2-4C52-544EC92C7E2D}"/>
+              </a:ext>
+            </a:extLst>
+          </p:cNvPr>
+          <p:cNvSpPr>
+            <a:spLocks noGrp="1"/>
+          </p:cNvSpPr>
+          <p:nvPr>
+            <p:ph type="title"/>
+          </p:nvPr>
+        </p:nvSpPr>
+        <p:spPr/>
+        <p:txBody>
+          <a:bodyPr/>
+          <a:lstStyle/>
+          <a:p>
+            <a:r>
+              <a:rPr lang="en-US" dirty="0"/>
+              <a:t>Space ship and green cube</a:t>
+            </a:r>
+          </a:p>
+        </p:txBody>
+      </p:sp>
+      <p:pic>
+        <p:nvPicPr>
+          <p:cNvPr id="5" name="Picture 4">
+            <a:extLst>
+              <a:ext uri="{FF2B5EF4-FFF2-40B4-BE49-F238E27FC236}">
+                <a16:creationId xmlns:a16="http://schemas.microsoft.com/office/drawing/2014/main" id="{E3CE7A71-2235-1200-04FE-3E754F489E00}"/>
+              </a:ext>
+            </a:extLst>
+          </p:cNvPr>
+          <p:cNvPicPr>
+            <a:picLocks noChangeAspect="1"/>
+          </p:cNvPicPr>
+          <p:nvPr/>
+        </p:nvPicPr>
+        <p:blipFill>
+          <a:blip r:embed="rId2"/>
+          <a:stretch>
+            <a:fillRect/>
+          </a:stretch>
+        </p:blipFill>
+        <p:spPr>
+          <a:xfrm>
+            <a:off x="1260848" y="2729138"/>
+            <a:ext cx="8686422" cy="1821346"/>
+          </a:xfrm>
+          <a:prstGeom prst="rect">
+            <a:avLst/>
+          </a:prstGeom>
+        </p:spPr>
+      </p:pic>
+    </p:spTree>
+    <p:extLst>
+      <p:ext uri="{BB962C8B-B14F-4D97-AF65-F5344CB8AC3E}">
+        <p14:creationId xmlns:p14="http://schemas.microsoft.com/office/powerpoint/2010/main" val="3561808767"/>
+      </p:ext>
+    </p:extLst>
+  </p:cSld>
+  <p:clrMapOvr>
+    <a:masterClrMapping/>
+  </p:clrMapOvr>
+</p:sld>
+</file>
+
+<file path=ppt/slides/slide8.xml><?xml version="1.0" encoding="utf-8"?>
+<p:sld xmlns:a="http://schemas.openxmlformats.org/drawingml/2006/main" xmlns:r="http://schemas.openxmlformats.org/officeDocument/2006/relationships" xmlns:p="http://schemas.openxmlformats.org/presentationml/2006/main">
+  <p:cSld>
+    <p:spTree>
+      <p:nvGrpSpPr>
+        <p:cNvPr id="1" name=""/>
+        <p:cNvGrpSpPr/>
+        <p:nvPr/>
+      </p:nvGrpSpPr>
+      <p:grpSpPr>
+        <a:xfrm>
+          <a:off x="0" y="0"/>
+          <a:ext cx="0" cy="0"/>
+          <a:chOff x="0" y="0"/>
+          <a:chExt cx="0" cy="0"/>
+        </a:xfrm>
+      </p:grpSpPr>
+      <p:sp>
+        <p:nvSpPr>
+          <p:cNvPr id="2" name="Title 1">
+            <a:extLst>
+              <a:ext uri="{FF2B5EF4-FFF2-40B4-BE49-F238E27FC236}">
+                <a16:creationId xmlns:a16="http://schemas.microsoft.com/office/drawing/2014/main" id="{1F36EA5E-C9B6-112B-B571-1B0261147BCB}"/>
+              </a:ext>
+            </a:extLst>
+          </p:cNvPr>
+          <p:cNvSpPr>
+            <a:spLocks noGrp="1"/>
+          </p:cNvSpPr>
+          <p:nvPr>
+            <p:ph type="title"/>
+          </p:nvPr>
+        </p:nvSpPr>
+        <p:spPr/>
+        <p:txBody>
+          <a:bodyPr/>
+          <a:lstStyle/>
+          <a:p>
+            <a:r>
+              <a:rPr lang="en-US" dirty="0"/>
+              <a:t>Simulating </a:t>
+            </a:r>
+            <a:r>
+              <a:rPr lang="en-US"/>
+              <a:t>some physics</a:t>
+            </a:r>
+          </a:p>
+        </p:txBody>
+      </p:sp>
+      <p:sp>
+        <p:nvSpPr>
+          <p:cNvPr id="3" name="Content Placeholder 2">
+            <a:extLst>
+              <a:ext uri="{FF2B5EF4-FFF2-40B4-BE49-F238E27FC236}">
+                <a16:creationId xmlns:a16="http://schemas.microsoft.com/office/drawing/2014/main" id="{29625D04-69E4-1897-646C-7233C97A0C9C}"/>
+              </a:ext>
+            </a:extLst>
+          </p:cNvPr>
+          <p:cNvSpPr>
+            <a:spLocks noGrp="1"/>
+          </p:cNvSpPr>
+          <p:nvPr>
+            <p:ph idx="1"/>
+          </p:nvPr>
+        </p:nvSpPr>
+        <p:spPr/>
+        <p:txBody>
+          <a:bodyPr/>
+          <a:lstStyle/>
+          <a:p>
+            <a:endParaRPr lang="en-US"/>
+          </a:p>
+        </p:txBody>
+      </p:sp>
+    </p:spTree>
+    <p:extLst>
+      <p:ext uri="{BB962C8B-B14F-4D97-AF65-F5344CB8AC3E}">
+        <p14:creationId xmlns:p14="http://schemas.microsoft.com/office/powerpoint/2010/main" val="3158254031"/>
+      </p:ext>
+    </p:extLst>
+  </p:cSld>
+  <p:clrMapOvr>
+    <a:masterClrMapping/>
+  </p:clrMapOvr>
+</p:sld>
+</file>
+
+<file path=ppt/slides/slide9.xml><?xml version="1.0" encoding="utf-8"?>
+<p:sld xmlns:a="http://schemas.openxmlformats.org/drawingml/2006/main" xmlns:r="http://schemas.openxmlformats.org/officeDocument/2006/relationships" xmlns:p="http://schemas.openxmlformats.org/presentationml/2006/main">
+  <p:cSld>
+    <p:spTree>
+      <p:nvGrpSpPr>
+        <p:cNvPr id="1" name=""/>
+        <p:cNvGrpSpPr/>
+        <p:nvPr/>
+      </p:nvGrpSpPr>
+      <p:grpSpPr>
+        <a:xfrm>
+          <a:off x="0" y="0"/>
+          <a:ext cx="0" cy="0"/>
+          <a:chOff x="0" y="0"/>
+          <a:chExt cx="0" cy="0"/>
+        </a:xfrm>
+      </p:grpSpPr>
+      <p:sp>
+        <p:nvSpPr>
+          <p:cNvPr id="2" name="Title 1">
+            <a:extLst>
+              <a:ext uri="{FF2B5EF4-FFF2-40B4-BE49-F238E27FC236}">
+                <a16:creationId xmlns:a16="http://schemas.microsoft.com/office/drawing/2014/main" id="{C0518053-F8C8-3B77-3459-2EB740E2D647}"/>
+              </a:ext>
+            </a:extLst>
+          </p:cNvPr>
+          <p:cNvSpPr>
+            <a:spLocks noGrp="1"/>
+          </p:cNvSpPr>
+          <p:nvPr>
+            <p:ph type="title"/>
+          </p:nvPr>
+        </p:nvSpPr>
+        <p:spPr/>
+        <p:txBody>
+          <a:bodyPr/>
+          <a:lstStyle/>
+          <a:p>
+            <a:r>
+              <a:rPr lang="en-US" dirty="0"/>
+              <a:t>Thanks</a:t>
+            </a:r>
+          </a:p>
+        </p:txBody>
+      </p:sp>
+      <p:sp>
+        <p:nvSpPr>
+          <p:cNvPr id="3" name="Content Placeholder 2">
+            <a:extLst>
+              <a:ext uri="{FF2B5EF4-FFF2-40B4-BE49-F238E27FC236}">
+                <a16:creationId xmlns:a16="http://schemas.microsoft.com/office/drawing/2014/main" id="{1B32CE7E-EC9F-93E4-DEA9-0DF98E1FBA26}"/>
+              </a:ext>
+            </a:extLst>
+          </p:cNvPr>
+          <p:cNvSpPr>
+            <a:spLocks noGrp="1"/>
+          </p:cNvSpPr>
+          <p:nvPr>
+            <p:ph idx="1"/>
+          </p:nvPr>
+        </p:nvSpPr>
+        <p:spPr/>
+        <p:txBody>
+          <a:bodyPr/>
+          <a:lstStyle/>
+          <a:p>
+            <a:pPr marL="0" indent="0">
+              <a:buNone/>
+            </a:pPr>
+            <a:endParaRPr lang="en-US" dirty="0"/>
+          </a:p>
+          <a:p>
+            <a:pPr marL="0" indent="0">
+              <a:buNone/>
+            </a:pPr>
+            <a:r>
+              <a:rPr lang="en-US" dirty="0"/>
+              <a:t>Ani (Anirudh) </a:t>
+            </a:r>
+            <a:r>
+              <a:rPr lang="en-US"/>
+              <a:t>Magesh helped </a:t>
+            </a:r>
+            <a:r>
+              <a:rPr lang="en-US" dirty="0"/>
+              <a:t>with the ball drop code and the ball-drop write up here</a:t>
+            </a:r>
+          </a:p>
+        </p:txBody>
+      </p:sp>
+    </p:spTree>
+    <p:extLst>
+      <p:ext uri="{BB962C8B-B14F-4D97-AF65-F5344CB8AC3E}">
+        <p14:creationId xmlns:p14="http://schemas.microsoft.com/office/powerpoint/2010/main" val="2038766729"/>
       </p:ext>
     </p:extLst>
   </p:cSld>

</xml_diff>